<commit_message>
Complete Unit 20 FBZ Comics Unmasked application
</commit_message>
<xml_diff>
--- a/submission/Unit20_FBZ_SOLID_OOP_Presentation.pptx
+++ b/submission/Unit20_FBZ_SOLID_OOP_Presentation.pptx
@@ -496,6 +496,10 @@
           </p:nvPr>
         </p:nvSpPr>
         <p:spPr/>
+        <p:txBody>
+          <a:bodyPr/>
+          <a:p/>
+        </p:txBody>
       </p:sp>
       <p:sp>
         <p:nvSpPr>
@@ -513,7 +517,7 @@
           <a:lstStyle/>
           <a:p>
             <a:r>
-              <a:t>Speaker notes — FBZ Dataset Processing. Explain the main points on screen using a concrete FBZ example. Relate the design decision back to the assignment criterion and the implemented code. Keep delivery within roughly 45–55 seconds for this slide.</a:t>
+              <a:t>The scenario is a comic-book shop that needs an encyclopedia around the British Library Comics Unmasked metadata. The important point is that this is not only a search script: the assignment evaluates how the application is designed, implemented and tested. The solution therefore separates the domain model, data access, application services and presentation. We use the real five-view dataset rather than a toy dataset, and the final evidence is generated from that data. This gives us a concrete way to demonstrate SOLID, clean coding, design patterns and automated testing rather than discussing them as isolated theory.</a:t>
             </a:r>
           </a:p>
         </p:txBody>
@@ -529,6 +533,10 @@
           </p:nvPr>
         </p:nvSpPr>
         <p:spPr/>
+        <p:txBody>
+          <a:bodyPr/>
+          <a:p/>
+        </p:txBody>
       </p:sp>
     </p:spTree>
   </p:cSld>
@@ -566,6 +574,10 @@
           </p:nvPr>
         </p:nvSpPr>
         <p:spPr/>
+        <p:txBody>
+          <a:bodyPr/>
+          <a:p/>
+        </p:txBody>
       </p:sp>
       <p:sp>
         <p:nvSpPr>
@@ -583,7 +595,7 @@
           <a:lstStyle/>
           <a:p>
             <a:r>
-              <a:t>Speaker notes — Real dataset validation. Explain the main points on screen using a concrete FBZ example. Relate the design decision back to the assignment criterion and the implemented code. Keep delivery within roughly 45–55 seconds for this slide.</a:t>
+              <a:t>The final acceptance run uses the actual Comics Unmasked package. All five views match the observed row counts and preserve leading-zero BL record IDs. The aggregated names view has 54,147 unique records. Exact genre filtering produces 4,793 Fantasy records, 1,929 Horror records and 9,356 Science Fiction records. The acceptance run also checks a real author-role search, a title containing Unicode characters, a missing ISBN, multi-value metadata and both title-order directions. This is important evidence because synthetic fixtures can prove algorithmic behaviour but cannot prove that our assumptions match the supplied dataset.</a:t>
             </a:r>
           </a:p>
         </p:txBody>
@@ -599,6 +611,10 @@
           </p:nvPr>
         </p:nvSpPr>
         <p:spPr/>
+        <p:txBody>
+          <a:bodyPr/>
+          <a:p/>
+        </p:txBody>
       </p:sp>
     </p:spTree>
   </p:cSld>
@@ -636,6 +652,10 @@
           </p:nvPr>
         </p:nvSpPr>
         <p:spPr/>
+        <p:txBody>
+          <a:bodyPr/>
+          <a:p/>
+        </p:txBody>
       </p:sp>
       <p:sp>
         <p:nvSpPr>
@@ -653,7 +673,7 @@
           <a:lstStyle/>
           <a:p>
             <a:r>
-              <a:t>Speaker notes — Automated testing. Explain the main points on screen using a concrete FBZ example. Relate the design decision back to the assignment criterion and the implemented code. Keep delivery within roughly 45–55 seconds for this slide.</a:t>
+              <a:t>The current automated suite has 30 passing tests. Unit tests focus on domain and strategy behaviour. Integration tests verify CSV-to-service boundaries and all five official views. End-to-end tests verify user-visible no-result and ordering behaviour. The real-data acceptance script checks the actual dataset and writes a machine-readable report. The &gt;100 requirement is demonstrated deterministically by running the same real Comic through 101 search inclusions and verifying that the notification is triggered. Coverage is useful as a diagnostic, but it is not treated as proof of correctness. pytest fixtures provide reusable test contexts, while the test-pyramid idea supports keeping fast focused tests as the larger base.</a:t>
             </a:r>
           </a:p>
         </p:txBody>
@@ -669,6 +689,10 @@
           </p:nvPr>
         </p:nvSpPr>
         <p:spPr/>
+        <p:txBody>
+          <a:bodyPr/>
+          <a:p/>
+        </p:txBody>
       </p:sp>
     </p:spTree>
   </p:cSld>
@@ -706,6 +730,10 @@
           </p:nvPr>
         </p:nvSpPr>
         <p:spPr/>
+        <p:txBody>
+          <a:bodyPr/>
+          <a:p/>
+        </p:txBody>
       </p:sp>
       <p:sp>
         <p:nvSpPr>
@@ -723,7 +751,7 @@
           <a:lstStyle/>
           <a:p>
             <a:r>
-              <a:t>Speaker notes — Evaluation + conclusion. Explain the main points on screen using a concrete FBZ example. Relate the design decision back to the assignment criterion and the implemented code. Keep delivery within roughly 45–55 seconds for this slide.</a:t>
+              <a:t>The final evaluation is deliberately balanced. SOLID improves testability and limits the blast radius of changes, but it adds indirection and learning cost. Strategy is justified by multiple search behaviours, Repository by multiple data sources, and aggregation by the real facet structure. Design patterns are not automatically good; using them without a problem can create unnecessary complexity, which is why the project uses only patterns with a clear purpose. Automated testing is valuable because this application repeats data-heavy workflows, but broad UI automation would be more expensive and brittle. The final result is therefore traceable from requirement to design, implementation, test and evidence.</a:t>
             </a:r>
           </a:p>
         </p:txBody>
@@ -739,6 +767,10 @@
           </p:nvPr>
         </p:nvSpPr>
         <p:spPr/>
+        <p:txBody>
+          <a:bodyPr/>
+          <a:p/>
+        </p:txBody>
       </p:sp>
     </p:spTree>
   </p:cSld>
@@ -776,6 +808,10 @@
           </p:nvPr>
         </p:nvSpPr>
         <p:spPr/>
+        <p:txBody>
+          <a:bodyPr/>
+          <a:p/>
+        </p:txBody>
       </p:sp>
       <p:sp>
         <p:nvSpPr>
@@ -793,7 +829,7 @@
           <a:lstStyle/>
           <a:p>
             <a:r>
-              <a:t>Speaker notes — The problem. Explain the main points on screen using a concrete FBZ example. Relate the design decision back to the assignment criterion and the implemented code. Keep delivery within roughly 45–55 seconds for this slide.</a:t>
+              <a:t>Encapsulation is visible in `Comic`, which owns catalogue state and operations such as tokenisation and author extraction. Abstraction is visible in `ComicRepository` and `SearchStrategy`, because callers use a small contract rather than depending on implementation details. Inheritance is used only where substitutability is meaningful: CSV, in-memory and XML repositories satisfy the repository contract, while concrete search strategies satisfy the strategy contract. Polymorphism then allows the same search service to work with title, author, genre or year strategies. The design avoids unnecessary domain inheritance because composition and dependency injection are more appropriate for the catalogue records.</a:t>
             </a:r>
           </a:p>
         </p:txBody>
@@ -809,6 +845,10 @@
           </p:nvPr>
         </p:nvSpPr>
         <p:spPr/>
+        <p:txBody>
+          <a:bodyPr/>
+          <a:p/>
+        </p:txBody>
       </p:sp>
     </p:spTree>
   </p:cSld>
@@ -846,6 +886,10 @@
           </p:nvPr>
         </p:nvSpPr>
         <p:spPr/>
+        <p:txBody>
+          <a:bodyPr/>
+          <a:p/>
+        </p:txBody>
       </p:sp>
       <p:sp>
         <p:nvSpPr>
@@ -863,7 +907,7 @@
           <a:lstStyle/>
           <a:p>
             <a:r>
-              <a:t>Speaker notes — OOP foundations. Explain the main points on screen using a concrete FBZ example. Relate the design decision back to the assignment criterion and the implemented code. Keep delivery within roughly 45–55 seconds for this slide.</a:t>
+              <a:t>There are several relationships to distinguish. A service has a dependency on a repository because it needs data but should not care whether that data comes from CSV, XML or memory. The repository contains a sequence of `Comic` objects, which is a composition of application state. The most important domain refinement is `Contributor`: the real names view has a person together with a role such as author, artist or editor. Earlier flattening of these values could make an author search return an editor. The final model preserves name and role together and derives `Comic.authors()` from explicit author or writer roles.</a:t>
             </a:r>
           </a:p>
         </p:txBody>
@@ -879,6 +923,10 @@
           </p:nvPr>
         </p:nvSpPr>
         <p:spPr/>
+        <p:txBody>
+          <a:bodyPr/>
+          <a:p/>
+        </p:txBody>
       </p:sp>
     </p:spTree>
   </p:cSld>
@@ -916,6 +964,10 @@
           </p:nvPr>
         </p:nvSpPr>
         <p:spPr/>
+        <p:txBody>
+          <a:bodyPr/>
+          <a:p/>
+        </p:txBody>
       </p:sp>
       <p:sp>
         <p:nvSpPr>
@@ -933,7 +985,7 @@
           <a:lstStyle/>
           <a:p>
             <a:r>
-              <a:t>Speaker notes — SOLID in the application. Explain the main points on screen using a concrete FBZ example. Relate the design decision back to the assignment criterion and the implemented code. Keep delivery within roughly 45–55 seconds for this slide.</a:t>
+              <a:t>Single Responsibility is demonstrated by keeping CSV parsing, domain modelling, search, favourites and presentation separate. Open/Closed is demonstrated by adding search algorithms as new Strategy implementations rather than modifying the existing service. Liskov Substitution means concrete repositories and strategies can be substituted wherever their contracts are expected. Interface Segregation is achieved with small repository and strategy contracts instead of one large interface. Dependency Inversion is especially valuable: services depend on `ComicRepository`, so tests can inject an in-memory repository. Chebanyuk and Markov's work supports treating these principles as structural design constraints rather than decorative terminology.</a:t>
             </a:r>
           </a:p>
         </p:txBody>
@@ -949,6 +1001,10 @@
           </p:nvPr>
         </p:nvSpPr>
         <p:spPr/>
+        <p:txBody>
+          <a:bodyPr/>
+          <a:p/>
+        </p:txBody>
       </p:sp>
     </p:spTree>
   </p:cSld>
@@ -986,6 +1042,10 @@
           </p:nvPr>
         </p:nvSpPr>
         <p:spPr/>
+        <p:txBody>
+          <a:bodyPr/>
+          <a:p/>
+        </p:txBody>
       </p:sp>
       <p:sp>
         <p:nvSpPr>
@@ -1003,7 +1063,7 @@
           <a:lstStyle/>
           <a:p>
             <a:r>
-              <a:t>Speaker notes — Clean coding. Explain the main points on screen using a concrete FBZ example. Relate the design decision back to the assignment criterion and the implemented code. Keep delivery within roughly 45–55 seconds for this slide.</a:t>
+              <a:t>Clean coding is more than formatting. The research describes clean code in terms of readability, maintainability, simplicity and modularisation. In FBZ, a monolithic procedure would parse CSV, aggregate rows, filter genres, sort titles and print output. That would make defects difficult to isolate and algorithmic complexity difficult to explain. Instead, the CSV repository parses, the aggregation repository handles repeated record IDs, the service coordinates business rules, and the CLI handles interaction. This makes each operation easier to test and change. It also keeps data structures visible: tuples hold immutable records, lists hold result sequences, and dictionaries support grouped results.</a:t>
             </a:r>
           </a:p>
         </p:txBody>
@@ -1019,6 +1079,10 @@
           </p:nvPr>
         </p:nvSpPr>
         <p:spPr/>
+        <p:txBody>
+          <a:bodyPr/>
+          <a:p/>
+        </p:txBody>
       </p:sp>
     </p:spTree>
   </p:cSld>
@@ -1056,6 +1120,10 @@
           </p:nvPr>
         </p:nvSpPr>
         <p:spPr/>
+        <p:txBody>
+          <a:bodyPr/>
+          <a:p/>
+        </p:txBody>
       </p:sp>
       <p:sp>
         <p:nvSpPr>
@@ -1073,7 +1141,7 @@
           <a:lstStyle/>
           <a:p>
             <a:r>
-              <a:t>Speaker notes — Data structures + algorithms. Explain the main points on screen using a concrete FBZ example. Relate the design decision back to the assignment criterion and the implemented code. Keep delivery within roughly 45–55 seconds for this slide.</a:t>
+              <a:t>The application intentionally loads the dataset into memory as required by the scenario. A tuple gives stable, immutable storage after loading. Filtering and basic search scan the sequence linearly, so their time complexity is O(n). Alphabetical sorting uses Python's stable sort and is O(n log n). Multi-value fields are tokenised so genre and topic operations do not treat the entire semicolon-separated string as one value. The real names view demonstrates why aggregation matters: 117,873 facet rows correspond to only 54,147 unique BL record IDs. We collapse those repeated rows without modifying the original source files.</a:t>
             </a:r>
           </a:p>
         </p:txBody>
@@ -1089,6 +1157,10 @@
           </p:nvPr>
         </p:nvSpPr>
         <p:spPr/>
+        <p:txBody>
+          <a:bodyPr/>
+          <a:p/>
+        </p:txBody>
       </p:sp>
     </p:spTree>
   </p:cSld>
@@ -1126,6 +1198,10 @@
           </p:nvPr>
         </p:nvSpPr>
         <p:spPr/>
+        <p:txBody>
+          <a:bodyPr/>
+          <a:p/>
+        </p:txBody>
       </p:sp>
       <p:sp>
         <p:nvSpPr>
@@ -1143,7 +1219,7 @@
           <a:lstStyle/>
           <a:p>
             <a:r>
-              <a:t>Speaker notes — Creational design. Explain the main points on screen using a concrete FBZ example. Relate the design decision back to the assignment criterion and the implemented code. Keep delivery within roughly 45–55 seconds for this slide.</a:t>
+              <a:t>The creational technique used is a simple factory. The application receives a search type such as title, author, genre or year, and `SearchStrategyFactory` creates the corresponding strategy object. This keeps object-construction decisions out of the caller. It is important to be technically precise: this project calls it a simple factory and does not claim that the implementation is the formal GoF Factory Method pattern. Tutorialspoint describes factory approaches as a way of hiding creation logic behind a common interface. Here the value is modest but concrete: adding another strategy does not require changing every client that constructs searches.</a:t>
             </a:r>
           </a:p>
         </p:txBody>
@@ -1159,6 +1235,10 @@
           </p:nvPr>
         </p:nvSpPr>
         <p:spPr/>
+        <p:txBody>
+          <a:bodyPr/>
+          <a:p/>
+        </p:txBody>
       </p:sp>
     </p:spTree>
   </p:cSld>
@@ -1196,6 +1276,10 @@
           </p:nvPr>
         </p:nvSpPr>
         <p:spPr/>
+        <p:txBody>
+          <a:bodyPr/>
+          <a:p/>
+        </p:txBody>
       </p:sp>
       <p:sp>
         <p:nvSpPr>
@@ -1213,7 +1297,7 @@
           <a:lstStyle/>
           <a:p>
             <a:r>
-              <a:t>Speaker notes — Structural design. Explain the main points on screen using a concrete FBZ example. Relate the design decision back to the assignment criterion and the implemented code. Keep delivery within roughly 45–55 seconds for this slide.</a:t>
+              <a:t>The Repository boundary separates storage from application behaviour. `CsvComicRepository` knows how to open the official CSV and validate its required columns. `InMemoryComicRepository` supports fast isolated tests. `XmlComicRepository` demonstrates that another source can satisfy the same contract. This is useful because the services do not need to know how the data was obtained. The real dataset also justified an aggregation repository: the names view is a facet view with repeated record IDs, so aggregation is a separate responsibility. This keeps source fidelity and user-facing one-record presentation from becoming tangled.</a:t>
             </a:r>
           </a:p>
         </p:txBody>
@@ -1229,6 +1313,10 @@
           </p:nvPr>
         </p:nvSpPr>
         <p:spPr/>
+        <p:txBody>
+          <a:bodyPr/>
+          <a:p/>
+        </p:txBody>
       </p:sp>
     </p:spTree>
   </p:cSld>
@@ -1266,6 +1354,10 @@
           </p:nvPr>
         </p:nvSpPr>
         <p:spPr/>
+        <p:txBody>
+          <a:bodyPr/>
+          <a:p/>
+        </p:txBody>
       </p:sp>
       <p:sp>
         <p:nvSpPr>
@@ -1283,7 +1375,7 @@
           <a:lstStyle/>
           <a:p>
             <a:r>
-              <a:t>Speaker notes — Behavioural design. Explain the main points on screen using a concrete FBZ example. Relate the design decision back to the assignment criterion and the implemented code. Keep delivery within roughly 45–55 seconds for this slide.</a:t>
+              <a:t>Strategy is the clearest behavioural pattern in the application. Title, author, genre and year searches are different algorithms, but the caller needs the same operation: search a sequence of Comics using a query. Each concrete strategy implements that common contract. This reduces a large conditional search method and makes each algorithm independently testable. The author strategy is also a good example of why patterns do not replace domain analysis: the strategy delegates to `Comic.authors()`, which understands the source's name-role relationship. A future ISBN or publisher strategy can be added without rewriting the existing search implementations.</a:t>
             </a:r>
           </a:p>
         </p:txBody>
@@ -1299,6 +1391,10 @@
           </p:nvPr>
         </p:nvSpPr>
         <p:spPr/>
+        <p:txBody>
+          <a:bodyPr/>
+          <a:p/>
+        </p:txBody>
       </p:sp>
     </p:spTree>
   </p:cSld>
@@ -4297,8 +4393,8 @@
         </p:nvSpPr>
         <p:spPr>
           <a:xfrm>
-            <a:off x="594360" y="411480"/>
-            <a:ext cx="10972800" cy="685800"/>
+            <a:off x="594360" y="384048"/>
+            <a:ext cx="10972800" cy="731520"/>
           </a:xfrm>
           <a:prstGeom prst="rect">
             <a:avLst/>
@@ -4317,7 +4413,7 @@
                   <a:srgbClr val="19232D"/>
                 </a:solidFill>
               </a:rPr>
-              <a:t>FBZ Dataset Processing</a:t>
+              <a:t>FBZ problem and objective</a:t>
             </a:r>
           </a:p>
         </p:txBody>
@@ -4330,8 +4426,8 @@
         </p:nvSpPr>
         <p:spPr>
           <a:xfrm>
-            <a:off x="685800" y="1417320"/>
-            <a:ext cx="10835640" cy="4434840"/>
+            <a:off x="685800" y="1325880"/>
+            <a:ext cx="10835640" cy="4526280"/>
           </a:xfrm>
           <a:prstGeom prst="roundRect">
             <a:avLst/>
@@ -4365,13 +4461,13 @@
           <a:p>
             <a:pPr algn="l"/>
             <a:r>
-              <a:rPr sz="2200" b="0">
+              <a:rPr sz="2100" b="0">
                 <a:solidFill>
                   <a:srgbClr val="19232D"/>
                 </a:solidFill>
               </a:rPr>
-              <a:t>Unit 20 — Applied Programming and Design Principles
-SOLID, OOP, design patterns and automated testing</a:t>
+              <a:t>Fantasy Bazaar needs a maintainable application for Comics Unmasked metadata.
+Goal: useful data processing + sound OOP design.</a:t>
             </a:r>
           </a:p>
         </p:txBody>
@@ -4384,8 +4480,8 @@
         </p:nvSpPr>
         <p:spPr>
           <a:xfrm>
-            <a:off x="685800" y="6217920"/>
-            <a:ext cx="10789920" cy="320040"/>
+            <a:off x="685800" y="6236208"/>
+            <a:ext cx="10789920" cy="274320"/>
           </a:xfrm>
           <a:prstGeom prst="rect">
             <a:avLst/>
@@ -4435,8 +4531,8 @@
         </p:nvSpPr>
         <p:spPr>
           <a:xfrm>
-            <a:off x="594360" y="411480"/>
-            <a:ext cx="10972800" cy="685800"/>
+            <a:off x="594360" y="384048"/>
+            <a:ext cx="10972800" cy="731520"/>
           </a:xfrm>
           <a:prstGeom prst="rect">
             <a:avLst/>
@@ -4468,8 +4564,8 @@
         </p:nvSpPr>
         <p:spPr>
           <a:xfrm>
-            <a:off x="685800" y="1417320"/>
-            <a:ext cx="10835640" cy="4434840"/>
+            <a:off x="685800" y="1325880"/>
+            <a:ext cx="10835640" cy="4526280"/>
           </a:xfrm>
           <a:prstGeom prst="roundRect">
             <a:avLst/>
@@ -4503,18 +4599,17 @@
           <a:p>
             <a:pPr algn="l"/>
             <a:r>
-              <a:rPr sz="2200" b="0">
+              <a:rPr sz="2100" b="0">
                 <a:solidFill>
                   <a:srgbClr val="19232D"/>
                 </a:solidFill>
               </a:rPr>
-              <a:t>Five official CSV views loaded successfully.
-records.csv: 57,746 rows
-names.csv: 117,873 rows
-titles.csv: 77,280 rows
-topics.csv: 77,919 rows
-classification.csv: 57,844 rows
-Aggregated names view: 54,147 unique BL records.</a:t>
+              <a:t>records.csv: 57,746
+names.csv: 117,873
+titles.csv: 77,280
+topics.csv: 77,919
+classification.csv: 57,844
+Fantasy 4,793 / Horror 1,929 / Science Fiction 9,356</a:t>
             </a:r>
           </a:p>
         </p:txBody>
@@ -4527,8 +4622,8 @@
         </p:nvSpPr>
         <p:spPr>
           <a:xfrm>
-            <a:off x="685800" y="6217920"/>
-            <a:ext cx="10789920" cy="320040"/>
+            <a:off x="685800" y="6236208"/>
+            <a:ext cx="10789920" cy="274320"/>
           </a:xfrm>
           <a:prstGeom prst="rect">
             <a:avLst/>
@@ -4578,8 +4673,8 @@
         </p:nvSpPr>
         <p:spPr>
           <a:xfrm>
-            <a:off x="594360" y="411480"/>
-            <a:ext cx="10972800" cy="685800"/>
+            <a:off x="594360" y="384048"/>
+            <a:ext cx="10972800" cy="731520"/>
           </a:xfrm>
           <a:prstGeom prst="rect">
             <a:avLst/>
@@ -4611,8 +4706,8 @@
         </p:nvSpPr>
         <p:spPr>
           <a:xfrm>
-            <a:off x="685800" y="1417320"/>
-            <a:ext cx="10835640" cy="4434840"/>
+            <a:off x="685800" y="1325880"/>
+            <a:ext cx="10835640" cy="4526280"/>
           </a:xfrm>
           <a:prstGeom prst="roundRect">
             <a:avLst/>
@@ -4646,15 +4741,17 @@
           <a:p>
             <a:pPr algn="l"/>
             <a:r>
-              <a:rPr sz="2200" b="0">
+              <a:rPr sz="2100" b="0">
                 <a:solidFill>
                   <a:srgbClr val="19232D"/>
                 </a:solidFill>
               </a:rPr>
-              <a:t>26 automated tests currently pass.
-Unit + integration + CLI/end-to-end + real-data acceptance
-Real genre records: Fantasy 4,793; Horror 1,929; Science Fiction 9,356.
-Coverage is used as a diagnostic, not proof of correctness.</a:t>
+              <a:t>29 automated tests pass
+Unit
+Integration
+CLI / E2E
+Real-data acceptance
+&gt;100 notification verified</a:t>
             </a:r>
           </a:p>
         </p:txBody>
@@ -4667,8 +4764,8 @@
         </p:nvSpPr>
         <p:spPr>
           <a:xfrm>
-            <a:off x="685800" y="6217920"/>
-            <a:ext cx="10789920" cy="320040"/>
+            <a:off x="685800" y="6236208"/>
+            <a:ext cx="10789920" cy="274320"/>
           </a:xfrm>
           <a:prstGeom prst="rect">
             <a:avLst/>
@@ -4688,6 +4785,40 @@
                 </a:solidFill>
               </a:rPr>
               <a:t>Unit 20 • FBZ • Slide 11/12</a:t>
+            </a:r>
+          </a:p>
+        </p:txBody>
+      </p:sp>
+      <p:sp>
+        <p:nvSpPr>
+          <p:cNvPr id="5" name="TextBox 4"/>
+          <p:cNvSpPr txBox="1"/>
+          <p:nvPr/>
+        </p:nvSpPr>
+        <p:spPr>
+          <a:xfrm>
+            <a:off x="6675120" y="6217920"/>
+            <a:ext cx="4754880" cy="320040"/>
+          </a:xfrm>
+          <a:prstGeom prst="rect">
+            <a:avLst/>
+          </a:prstGeom>
+          <a:noFill/>
+        </p:spPr>
+        <p:txBody>
+          <a:bodyPr wrap="none">
+            <a:spAutoFit/>
+          </a:bodyPr>
+          <a:lstStyle/>
+          <a:p>
+            <a:pPr algn="r"/>
+            <a:r>
+              <a:rPr sz="900" i="1">
+                <a:solidFill>
+                  <a:srgbClr val="646E78"/>
+                </a:solidFill>
+              </a:rPr>
+              <a:t>Research: pytest (n.d.); Fowler (2012)</a:t>
             </a:r>
           </a:p>
         </p:txBody>
@@ -4718,8 +4849,8 @@
         </p:nvSpPr>
         <p:spPr>
           <a:xfrm>
-            <a:off x="594360" y="411480"/>
-            <a:ext cx="10972800" cy="685800"/>
+            <a:off x="594360" y="384048"/>
+            <a:ext cx="10972800" cy="731520"/>
           </a:xfrm>
           <a:prstGeom prst="rect">
             <a:avLst/>
@@ -4738,7 +4869,7 @@
                   <a:srgbClr val="19232D"/>
                 </a:solidFill>
               </a:rPr>
-              <a:t>Evaluation + conclusion</a:t>
+              <a:t>Evaluation and conclusion</a:t>
             </a:r>
           </a:p>
         </p:txBody>
@@ -4751,8 +4882,8 @@
         </p:nvSpPr>
         <p:spPr>
           <a:xfrm>
-            <a:off x="685800" y="1417320"/>
-            <a:ext cx="10835640" cy="4434840"/>
+            <a:off x="685800" y="1325880"/>
+            <a:ext cx="10835640" cy="4526280"/>
           </a:xfrm>
           <a:prstGeom prst="roundRect">
             <a:avLst/>
@@ -4786,15 +4917,15 @@
           <a:p>
             <a:pPr algn="l"/>
             <a:r>
-              <a:rPr sz="2200" b="0">
+              <a:rPr sz="2100" b="0">
                 <a:solidFill>
                   <a:srgbClr val="19232D"/>
                 </a:solidFill>
               </a:rPr>
-              <a:t>SOLID improves change isolation and testability but adds abstraction overhead.
-Patterns are valuable when they address real variation.
-Automation reduces regression risk but must be maintained.
-The final design is traceable from requirement → class → implementation → test → evidence.</a:t>
+              <a:t>SOLID improves change isolation.
+Patterns solve concrete variation.
+Automation reduces regression risk.
+Abstraction has a cost.</a:t>
             </a:r>
           </a:p>
         </p:txBody>
@@ -4807,8 +4938,8 @@
         </p:nvSpPr>
         <p:spPr>
           <a:xfrm>
-            <a:off x="685800" y="6217920"/>
-            <a:ext cx="10789920" cy="320040"/>
+            <a:off x="685800" y="6236208"/>
+            <a:ext cx="10789920" cy="274320"/>
           </a:xfrm>
           <a:prstGeom prst="rect">
             <a:avLst/>
@@ -4828,6 +4959,40 @@
                 </a:solidFill>
               </a:rPr>
               <a:t>Unit 20 • FBZ • Slide 12/12</a:t>
+            </a:r>
+          </a:p>
+        </p:txBody>
+      </p:sp>
+      <p:sp>
+        <p:nvSpPr>
+          <p:cNvPr id="5" name="TextBox 4"/>
+          <p:cNvSpPr txBox="1"/>
+          <p:nvPr/>
+        </p:nvSpPr>
+        <p:spPr>
+          <a:xfrm>
+            <a:off x="6675120" y="6217920"/>
+            <a:ext cx="4754880" cy="320040"/>
+          </a:xfrm>
+          <a:prstGeom prst="rect">
+            <a:avLst/>
+          </a:prstGeom>
+          <a:noFill/>
+        </p:spPr>
+        <p:txBody>
+          <a:bodyPr wrap="none">
+            <a:spAutoFit/>
+          </a:bodyPr>
+          <a:lstStyle/>
+          <a:p>
+            <a:pPr algn="r"/>
+            <a:r>
+              <a:rPr sz="900" i="1">
+                <a:solidFill>
+                  <a:srgbClr val="646E78"/>
+                </a:solidFill>
+              </a:rPr>
+              <a:t>Research: Subburaj et al. (2015); SmartBear (n.d.)</a:t>
             </a:r>
           </a:p>
         </p:txBody>
@@ -4858,8 +5023,8 @@
         </p:nvSpPr>
         <p:spPr>
           <a:xfrm>
-            <a:off x="594360" y="411480"/>
-            <a:ext cx="10972800" cy="685800"/>
+            <a:off x="594360" y="384048"/>
+            <a:ext cx="10972800" cy="731520"/>
           </a:xfrm>
           <a:prstGeom prst="rect">
             <a:avLst/>
@@ -4878,7 +5043,7 @@
                   <a:srgbClr val="19232D"/>
                 </a:solidFill>
               </a:rPr>
-              <a:t>The problem</a:t>
+              <a:t>OOP foundations</a:t>
             </a:r>
           </a:p>
         </p:txBody>
@@ -4891,8 +5056,8 @@
         </p:nvSpPr>
         <p:spPr>
           <a:xfrm>
-            <a:off x="685800" y="1417320"/>
-            <a:ext cx="10835640" cy="4434840"/>
+            <a:off x="685800" y="1325880"/>
+            <a:ext cx="10835640" cy="4526280"/>
           </a:xfrm>
           <a:prstGeom prst="roundRect">
             <a:avLst/>
@@ -4926,13 +5091,15 @@
           <a:p>
             <a:pPr algn="l"/>
             <a:r>
-              <a:rPr sz="2200" b="0">
+              <a:rPr sz="2100" b="0">
                 <a:solidFill>
                   <a:srgbClr val="19232D"/>
                 </a:solidFill>
               </a:rPr>
-              <a:t>Fantasy Bazaar needs a maintainable encyclopedia for the British Library Comics Unmasked metadata.
-The application must search, filter, group, sort, save an in-memory search list and report popular searches.</a:t>
+              <a:t>Encapsulation
+Abstraction
+Inheritance
+Polymorphism</a:t>
             </a:r>
           </a:p>
         </p:txBody>
@@ -4945,8 +5112,8 @@
         </p:nvSpPr>
         <p:spPr>
           <a:xfrm>
-            <a:off x="685800" y="6217920"/>
-            <a:ext cx="10789920" cy="320040"/>
+            <a:off x="685800" y="6236208"/>
+            <a:ext cx="10789920" cy="274320"/>
           </a:xfrm>
           <a:prstGeom prst="rect">
             <a:avLst/>
@@ -4996,8 +5163,8 @@
         </p:nvSpPr>
         <p:spPr>
           <a:xfrm>
-            <a:off x="594360" y="411480"/>
-            <a:ext cx="10972800" cy="685800"/>
+            <a:off x="594360" y="384048"/>
+            <a:ext cx="10972800" cy="731520"/>
           </a:xfrm>
           <a:prstGeom prst="rect">
             <a:avLst/>
@@ -5016,7 +5183,7 @@
                   <a:srgbClr val="19232D"/>
                 </a:solidFill>
               </a:rPr>
-              <a:t>OOP foundations</a:t>
+              <a:t>Class relationships</a:t>
             </a:r>
           </a:p>
         </p:txBody>
@@ -5029,8 +5196,8 @@
         </p:nvSpPr>
         <p:spPr>
           <a:xfrm>
-            <a:off x="685800" y="1417320"/>
-            <a:ext cx="10835640" cy="4434840"/>
+            <a:off x="685800" y="1325880"/>
+            <a:ext cx="10835640" cy="4526280"/>
           </a:xfrm>
           <a:prstGeom prst="roundRect">
             <a:avLst/>
@@ -5064,15 +5231,14 @@
           <a:p>
             <a:pPr algn="l"/>
             <a:r>
-              <a:rPr sz="2200" b="0">
+              <a:rPr sz="2100" b="0">
                 <a:solidFill>
                   <a:srgbClr val="19232D"/>
                 </a:solidFill>
               </a:rPr>
-              <a:t>Encapsulation → Comic domain objects
-Abstraction → repository and strategy contracts
-Polymorphism → interchangeable search algorithms
-Inheritance → purposeful abstract contracts</a:t>
+              <a:t>Services depend on repository abstractions.
+Strategies share a common contract.
+`Comic` contains contributor relationships.</a:t>
             </a:r>
           </a:p>
         </p:txBody>
@@ -5085,8 +5251,8 @@
         </p:nvSpPr>
         <p:spPr>
           <a:xfrm>
-            <a:off x="685800" y="6217920"/>
-            <a:ext cx="10789920" cy="320040"/>
+            <a:off x="685800" y="6236208"/>
+            <a:ext cx="10789920" cy="274320"/>
           </a:xfrm>
           <a:prstGeom prst="rect">
             <a:avLst/>
@@ -5136,8 +5302,8 @@
         </p:nvSpPr>
         <p:spPr>
           <a:xfrm>
-            <a:off x="594360" y="411480"/>
-            <a:ext cx="10972800" cy="685800"/>
+            <a:off x="594360" y="384048"/>
+            <a:ext cx="10972800" cy="731520"/>
           </a:xfrm>
           <a:prstGeom prst="rect">
             <a:avLst/>
@@ -5156,7 +5322,7 @@
                   <a:srgbClr val="19232D"/>
                 </a:solidFill>
               </a:rPr>
-              <a:t>SOLID in the application</a:t>
+              <a:t>SOLID in FBZ</a:t>
             </a:r>
           </a:p>
         </p:txBody>
@@ -5169,8 +5335,8 @@
         </p:nvSpPr>
         <p:spPr>
           <a:xfrm>
-            <a:off x="685800" y="1417320"/>
-            <a:ext cx="10835640" cy="4434840"/>
+            <a:off x="685800" y="1325880"/>
+            <a:ext cx="10835640" cy="4526280"/>
           </a:xfrm>
           <a:prstGeom prst="roundRect">
             <a:avLst/>
@@ -5204,16 +5370,16 @@
           <a:p>
             <a:pPr algn="l"/>
             <a:r>
-              <a:rPr sz="2200" b="0">
+              <a:rPr sz="2100" b="0">
                 <a:solidFill>
                   <a:srgbClr val="19232D"/>
                 </a:solidFill>
               </a:rPr>
-              <a:t>S — one responsibility per major class
-O — extend via new SearchStrategy implementations
-L — concrete strategies satisfy the same contract
-I — small focused interfaces
-D — services depend on ComicRepository abstraction</a:t>
+              <a:t>SRP
+OCP
+LSP
+ISP
+DIP</a:t>
             </a:r>
           </a:p>
         </p:txBody>
@@ -5226,8 +5392,8 @@
         </p:nvSpPr>
         <p:spPr>
           <a:xfrm>
-            <a:off x="685800" y="6217920"/>
-            <a:ext cx="10789920" cy="320040"/>
+            <a:off x="685800" y="6236208"/>
+            <a:ext cx="10789920" cy="274320"/>
           </a:xfrm>
           <a:prstGeom prst="rect">
             <a:avLst/>
@@ -5247,6 +5413,40 @@
                 </a:solidFill>
               </a:rPr>
               <a:t>Unit 20 • FBZ • Slide 4/12</a:t>
+            </a:r>
+          </a:p>
+        </p:txBody>
+      </p:sp>
+      <p:sp>
+        <p:nvSpPr>
+          <p:cNvPr id="5" name="TextBox 4"/>
+          <p:cNvSpPr txBox="1"/>
+          <p:nvPr/>
+        </p:nvSpPr>
+        <p:spPr>
+          <a:xfrm>
+            <a:off x="6675120" y="6217920"/>
+            <a:ext cx="4754880" cy="320040"/>
+          </a:xfrm>
+          <a:prstGeom prst="rect">
+            <a:avLst/>
+          </a:prstGeom>
+          <a:noFill/>
+        </p:spPr>
+        <p:txBody>
+          <a:bodyPr wrap="none">
+            <a:spAutoFit/>
+          </a:bodyPr>
+          <a:lstStyle/>
+          <a:p>
+            <a:pPr algn="r"/>
+            <a:r>
+              <a:rPr sz="900" i="1">
+                <a:solidFill>
+                  <a:srgbClr val="646E78"/>
+                </a:solidFill>
+              </a:rPr>
+              <a:t>Research: Chebanyuk and Markov (2016)</a:t>
             </a:r>
           </a:p>
         </p:txBody>
@@ -5277,8 +5477,8 @@
         </p:nvSpPr>
         <p:spPr>
           <a:xfrm>
-            <a:off x="594360" y="411480"/>
-            <a:ext cx="10972800" cy="685800"/>
+            <a:off x="594360" y="384048"/>
+            <a:ext cx="10972800" cy="731520"/>
           </a:xfrm>
           <a:prstGeom prst="rect">
             <a:avLst/>
@@ -5310,8 +5510,8 @@
         </p:nvSpPr>
         <p:spPr>
           <a:xfrm>
-            <a:off x="685800" y="1417320"/>
-            <a:ext cx="10835640" cy="4434840"/>
+            <a:off x="685800" y="1325880"/>
+            <a:ext cx="10835640" cy="4526280"/>
           </a:xfrm>
           <a:prstGeom prst="roundRect">
             <a:avLst/>
@@ -5345,16 +5545,16 @@
           <a:p>
             <a:pPr algn="l"/>
             <a:r>
-              <a:rPr sz="2200" b="0">
+              <a:rPr sz="2100" b="0">
                 <a:solidFill>
                   <a:srgbClr val="19232D"/>
                 </a:solidFill>
               </a:rPr>
-              <a:t>Explicit names and type hints
-Immutable domain model
-CSV I/O isolated from business logic
-Validation at the input boundary
-Deterministic search/sort operations</a:t>
+              <a:t>Explicit names and types
+Focused methods
+Validation at boundaries
+Immutable domain state
+Separated I/O and business logic</a:t>
             </a:r>
           </a:p>
         </p:txBody>
@@ -5367,8 +5567,8 @@
         </p:nvSpPr>
         <p:spPr>
           <a:xfrm>
-            <a:off x="685800" y="6217920"/>
-            <a:ext cx="10789920" cy="320040"/>
+            <a:off x="685800" y="6236208"/>
+            <a:ext cx="10789920" cy="274320"/>
           </a:xfrm>
           <a:prstGeom prst="rect">
             <a:avLst/>
@@ -5388,6 +5588,40 @@
                 </a:solidFill>
               </a:rPr>
               <a:t>Unit 20 • FBZ • Slide 5/12</a:t>
+            </a:r>
+          </a:p>
+        </p:txBody>
+      </p:sp>
+      <p:sp>
+        <p:nvSpPr>
+          <p:cNvPr id="5" name="TextBox 4"/>
+          <p:cNvSpPr txBox="1"/>
+          <p:nvPr/>
+        </p:nvSpPr>
+        <p:spPr>
+          <a:xfrm>
+            <a:off x="6675120" y="6217920"/>
+            <a:ext cx="4754880" cy="320040"/>
+          </a:xfrm>
+          <a:prstGeom prst="rect">
+            <a:avLst/>
+          </a:prstGeom>
+          <a:noFill/>
+        </p:spPr>
+        <p:txBody>
+          <a:bodyPr wrap="none">
+            <a:spAutoFit/>
+          </a:bodyPr>
+          <a:lstStyle/>
+          <a:p>
+            <a:pPr algn="r"/>
+            <a:r>
+              <a:rPr sz="900" i="1">
+                <a:solidFill>
+                  <a:srgbClr val="646E78"/>
+                </a:solidFill>
+              </a:rPr>
+              <a:t>Research: Mark (2023); Cocca (2023)</a:t>
             </a:r>
           </a:p>
         </p:txBody>
@@ -5418,8 +5652,8 @@
         </p:nvSpPr>
         <p:spPr>
           <a:xfrm>
-            <a:off x="594360" y="411480"/>
-            <a:ext cx="10972800" cy="685800"/>
+            <a:off x="594360" y="384048"/>
+            <a:ext cx="10972800" cy="731520"/>
           </a:xfrm>
           <a:prstGeom prst="rect">
             <a:avLst/>
@@ -5438,7 +5672,7 @@
                   <a:srgbClr val="19232D"/>
                 </a:solidFill>
               </a:rPr>
-              <a:t>Data structures + algorithms</a:t>
+              <a:t>Data structures and algorithms</a:t>
             </a:r>
           </a:p>
         </p:txBody>
@@ -5451,8 +5685,8 @@
         </p:nvSpPr>
         <p:spPr>
           <a:xfrm>
-            <a:off x="685800" y="1417320"/>
-            <a:ext cx="10835640" cy="4434840"/>
+            <a:off x="685800" y="1325880"/>
+            <a:ext cx="10835640" cy="4526280"/>
           </a:xfrm>
           <a:prstGeom prst="roundRect">
             <a:avLst/>
@@ -5486,16 +5720,16 @@
           <a:p>
             <a:pPr algn="l"/>
             <a:r>
-              <a:rPr sz="2200" b="0">
+              <a:rPr sz="2100" b="0">
                 <a:solidFill>
                   <a:srgbClr val="19232D"/>
                 </a:solidFill>
               </a:rPr>
-              <a:t>In-memory tuple of Comic objects
+              <a:t>Tuple-backed in-memory records
 Linear search: O(n)
-Alphabetical sort: O(n log n)
-Counter-style frequency aggregation
-Aggregation by BL record ID solves repeated facet rows</a:t>
+Sorting: O(n log n)
+Token aggregation
+Real names view: 117,873 rows → 54,147 records</a:t>
             </a:r>
           </a:p>
         </p:txBody>
@@ -5508,8 +5742,8 @@
         </p:nvSpPr>
         <p:spPr>
           <a:xfrm>
-            <a:off x="685800" y="6217920"/>
-            <a:ext cx="10789920" cy="320040"/>
+            <a:off x="685800" y="6236208"/>
+            <a:ext cx="10789920" cy="274320"/>
           </a:xfrm>
           <a:prstGeom prst="rect">
             <a:avLst/>
@@ -5559,8 +5793,8 @@
         </p:nvSpPr>
         <p:spPr>
           <a:xfrm>
-            <a:off x="594360" y="411480"/>
-            <a:ext cx="10972800" cy="685800"/>
+            <a:off x="594360" y="384048"/>
+            <a:ext cx="10972800" cy="731520"/>
           </a:xfrm>
           <a:prstGeom prst="rect">
             <a:avLst/>
@@ -5579,7 +5813,7 @@
                   <a:srgbClr val="19232D"/>
                 </a:solidFill>
               </a:rPr>
-              <a:t>Creational design</a:t>
+              <a:t>Creational pattern</a:t>
             </a:r>
           </a:p>
         </p:txBody>
@@ -5592,8 +5826,8 @@
         </p:nvSpPr>
         <p:spPr>
           <a:xfrm>
-            <a:off x="685800" y="1417320"/>
-            <a:ext cx="10835640" cy="4434840"/>
+            <a:off x="685800" y="1325880"/>
+            <a:ext cx="10835640" cy="4526280"/>
           </a:xfrm>
           <a:prstGeom prst="roundRect">
             <a:avLst/>
@@ -5627,14 +5861,14 @@
           <a:p>
             <a:pPr algn="l"/>
             <a:r>
-              <a:rPr sz="2200" b="0">
+              <a:rPr sz="2100" b="0">
                 <a:solidFill>
                   <a:srgbClr val="19232D"/>
                 </a:solidFill>
               </a:rPr>
-              <a:t>Simple Factory: SearchStrategyFactory
-Centralises construction of concrete search behaviours.
-This is intentionally documented as a simple factory, not incorrectly labelled the formal GoF Factory Method.</a:t>
+              <a:t>`SearchStrategyFactory`
+Centralised strategy construction
+Simple Factory, not formal Factory Method</a:t>
             </a:r>
           </a:p>
         </p:txBody>
@@ -5647,8 +5881,8 @@
         </p:nvSpPr>
         <p:spPr>
           <a:xfrm>
-            <a:off x="685800" y="6217920"/>
-            <a:ext cx="10789920" cy="320040"/>
+            <a:off x="685800" y="6236208"/>
+            <a:ext cx="10789920" cy="274320"/>
           </a:xfrm>
           <a:prstGeom prst="rect">
             <a:avLst/>
@@ -5668,6 +5902,40 @@
                 </a:solidFill>
               </a:rPr>
               <a:t>Unit 20 • FBZ • Slide 7/12</a:t>
+            </a:r>
+          </a:p>
+        </p:txBody>
+      </p:sp>
+      <p:sp>
+        <p:nvSpPr>
+          <p:cNvPr id="5" name="TextBox 4"/>
+          <p:cNvSpPr txBox="1"/>
+          <p:nvPr/>
+        </p:nvSpPr>
+        <p:spPr>
+          <a:xfrm>
+            <a:off x="6675120" y="6217920"/>
+            <a:ext cx="4754880" cy="320040"/>
+          </a:xfrm>
+          <a:prstGeom prst="rect">
+            <a:avLst/>
+          </a:prstGeom>
+          <a:noFill/>
+        </p:spPr>
+        <p:txBody>
+          <a:bodyPr wrap="none">
+            <a:spAutoFit/>
+          </a:bodyPr>
+          <a:lstStyle/>
+          <a:p>
+            <a:pPr algn="r"/>
+            <a:r>
+              <a:rPr sz="900" i="1">
+                <a:solidFill>
+                  <a:srgbClr val="646E78"/>
+                </a:solidFill>
+              </a:rPr>
+              <a:t>Research: Tutorialspoint (n.d.)</a:t>
             </a:r>
           </a:p>
         </p:txBody>
@@ -5698,8 +5966,8 @@
         </p:nvSpPr>
         <p:spPr>
           <a:xfrm>
-            <a:off x="594360" y="411480"/>
-            <a:ext cx="10972800" cy="685800"/>
+            <a:off x="594360" y="384048"/>
+            <a:ext cx="10972800" cy="731520"/>
           </a:xfrm>
           <a:prstGeom prst="rect">
             <a:avLst/>
@@ -5718,7 +5986,7 @@
                   <a:srgbClr val="19232D"/>
                 </a:solidFill>
               </a:rPr>
-              <a:t>Structural design</a:t>
+              <a:t>Structural / architectural boundary</a:t>
             </a:r>
           </a:p>
         </p:txBody>
@@ -5731,8 +5999,8 @@
         </p:nvSpPr>
         <p:spPr>
           <a:xfrm>
-            <a:off x="685800" y="1417320"/>
-            <a:ext cx="10835640" cy="4434840"/>
+            <a:off x="685800" y="1325880"/>
+            <a:ext cx="10835640" cy="4526280"/>
           </a:xfrm>
           <a:prstGeom prst="roundRect">
             <a:avLst/>
@@ -5766,14 +6034,15 @@
           <a:p>
             <a:pPr algn="l"/>
             <a:r>
-              <a:rPr sz="2200" b="0">
+              <a:rPr sz="2100" b="0">
                 <a:solidFill>
                   <a:srgbClr val="19232D"/>
                 </a:solidFill>
               </a:rPr>
               <a:t>Repository abstraction
-CSV repository handles source I/O while services remain storage-agnostic.
-An XML repository adapter is also included for future Phase 2 sources.</a:t>
+CSV source
+In-memory source
+XML adapter</a:t>
             </a:r>
           </a:p>
         </p:txBody>
@@ -5786,8 +6055,8 @@
         </p:nvSpPr>
         <p:spPr>
           <a:xfrm>
-            <a:off x="685800" y="6217920"/>
-            <a:ext cx="10789920" cy="320040"/>
+            <a:off x="685800" y="6236208"/>
+            <a:ext cx="10789920" cy="274320"/>
           </a:xfrm>
           <a:prstGeom prst="rect">
             <a:avLst/>
@@ -5837,8 +6106,8 @@
         </p:nvSpPr>
         <p:spPr>
           <a:xfrm>
-            <a:off x="594360" y="411480"/>
-            <a:ext cx="10972800" cy="685800"/>
+            <a:off x="594360" y="384048"/>
+            <a:ext cx="10972800" cy="731520"/>
           </a:xfrm>
           <a:prstGeom prst="rect">
             <a:avLst/>
@@ -5857,7 +6126,7 @@
                   <a:srgbClr val="19232D"/>
                 </a:solidFill>
               </a:rPr>
-              <a:t>Behavioural design</a:t>
+              <a:t>Behavioural pattern</a:t>
             </a:r>
           </a:p>
         </p:txBody>
@@ -5870,8 +6139,8 @@
         </p:nvSpPr>
         <p:spPr>
           <a:xfrm>
-            <a:off x="685800" y="1417320"/>
-            <a:ext cx="10835640" cy="4434840"/>
+            <a:off x="685800" y="1325880"/>
+            <a:ext cx="10835640" cy="4526280"/>
           </a:xfrm>
           <a:prstGeom prst="roundRect">
             <a:avLst/>
@@ -5905,14 +6174,14 @@
           <a:p>
             <a:pPr algn="l"/>
             <a:r>
-              <a:rPr sz="2200" b="0">
+              <a:rPr sz="2100" b="0">
                 <a:solidFill>
                   <a:srgbClr val="19232D"/>
                 </a:solidFill>
               </a:rPr>
               <a:t>Strategy pattern
-Title, Author, Genre and Year search algorithms implement one common contract.
-A new strategy can be added without rewriting the service.</a:t>
+Title / Author / Genre / Year
+Interchangeable algorithms</a:t>
             </a:r>
           </a:p>
         </p:txBody>
@@ -5925,8 +6194,8 @@
         </p:nvSpPr>
         <p:spPr>
           <a:xfrm>
-            <a:off x="685800" y="6217920"/>
-            <a:ext cx="10789920" cy="320040"/>
+            <a:off x="685800" y="6236208"/>
+            <a:ext cx="10789920" cy="274320"/>
           </a:xfrm>
           <a:prstGeom prst="rect">
             <a:avLst/>
@@ -5946,6 +6215,40 @@
                 </a:solidFill>
               </a:rPr>
               <a:t>Unit 20 • FBZ • Slide 9/12</a:t>
+            </a:r>
+          </a:p>
+        </p:txBody>
+      </p:sp>
+      <p:sp>
+        <p:nvSpPr>
+          <p:cNvPr id="5" name="TextBox 4"/>
+          <p:cNvSpPr txBox="1"/>
+          <p:nvPr/>
+        </p:nvSpPr>
+        <p:spPr>
+          <a:xfrm>
+            <a:off x="6675120" y="6217920"/>
+            <a:ext cx="4754880" cy="320040"/>
+          </a:xfrm>
+          <a:prstGeom prst="rect">
+            <a:avLst/>
+          </a:prstGeom>
+          <a:noFill/>
+        </p:spPr>
+        <p:txBody>
+          <a:bodyPr wrap="none">
+            <a:spAutoFit/>
+          </a:bodyPr>
+          <a:lstStyle/>
+          <a:p>
+            <a:pPr algn="r"/>
+            <a:r>
+              <a:rPr sz="900" i="1">
+                <a:solidFill>
+                  <a:srgbClr val="646E78"/>
+                </a:solidFill>
+              </a:rPr>
+              <a:t>Research: Refactoring.Guru (n.d.)</a:t>
             </a:r>
           </a:p>
         </p:txBody>

</xml_diff>

<commit_message>
Finalize Unit 20 FBZ requirements and evidence
</commit_message>
<xml_diff>
--- a/submission/Unit20_FBZ_SOLID_OOP_Presentation.pptx
+++ b/submission/Unit20_FBZ_SOLID_OOP_Presentation.pptx
@@ -595,7 +595,7 @@
           <a:lstStyle/>
           <a:p>
             <a:r>
-              <a:t>The final acceptance run uses the actual Comics Unmasked package. All five views match the observed row counts and preserve leading-zero BL record IDs. The aggregated names view has 54,147 unique records. Exact genre filtering produces 4,793 Fantasy records, 1,929 Horror records and 9,356 Science Fiction records. The acceptance run also checks a real author-role search, a title containing Unicode characters, a missing ISBN, multi-value metadata and both title-order directions. This is important evidence because synthetic fixtures can prove algorithmic behaviour but cannot prove that our assumptions match the supplied dataset.</a:t>
+              <a:t>The final acceptance run uses the actual Comics Unmasked package. All five views match the observed row counts and preserve leading-zero BL record IDs. The aggregated names view has 54,147 unique records. Exact genre filtering produces 4,793 Fantasy records, 1,929 Horror records and 9,356 Science Fiction records. The acceptance run also checks a real author-role search, a title containing Unicode characters, universal missing-value display, a missing ISBN, consistent multi-value metadata display and both title-order directions. This is important evidence because synthetic fixtures can prove algorithmic behaviour but cannot prove that our assumptions match the supplied dataset.</a:t>
             </a:r>
           </a:p>
         </p:txBody>
@@ -673,7 +673,7 @@
           <a:lstStyle/>
           <a:p>
             <a:r>
-              <a:t>The current automated suite has 30 passing tests. Unit tests focus on domain and strategy behaviour. Integration tests verify CSV-to-service boundaries and all five official views. End-to-end tests verify user-visible no-result and ordering behaviour. The real-data acceptance script checks the actual dataset and writes a machine-readable report. The &gt;100 requirement is demonstrated deterministically by running the same real Comic through 101 search inclusions and verifying that the notification is triggered. Coverage is useful as a diagnostic, but it is not treated as proof of correctness. pytest fixtures provide reusable test contexts, while the test-pyramid idea supports keeping fast focused tests as the larger base.</a:t>
+              <a:t>The current automated suite has 33 passing tests. Unit tests focus on domain and strategy behaviour. Integration tests verify CSV-to-service boundaries and all five official views. End-to-end tests verify user-visible no-result and ordering behaviour. The real-data acceptance script checks the actual dataset and writes a machine-readable report. The &gt;100 requirement is demonstrated deterministically by running the same real Comic through 101 search inclusions and verifying that the notification is triggered. Coverage is useful as a diagnostic, but it is not treated as proof of correctness. pytest fixtures provide reusable test contexts, while the test-pyramid idea supports keeping fast focused tests as the larger base.</a:t>
             </a:r>
           </a:p>
         </p:txBody>
@@ -4746,7 +4746,7 @@
                   <a:srgbClr val="19232D"/>
                 </a:solidFill>
               </a:rPr>
-              <a:t>29 automated tests pass
+              <a:t>33 automated tests pass
 Unit
 Integration
 CLI / E2E

</xml_diff>